<commit_message>
feat: add Danil reporting pack
</commit_message>
<xml_diff>
--- a/artifacts/slides.pptx
+++ b/artifacts/slides.pptx
@@ -4,9 +4,6 @@
   <p:sldMasterIdLst>
     <p:sldMasterId id="2147483648" r:id="rId1"/>
   </p:sldMasterIdLst>
-  <p:notesMasterIdLst>
-    <p:notesMasterId r:id="rId13"/>
-  </p:notesMasterIdLst>
   <p:sldIdLst>
     <p:sldId id="256" r:id="rId2"/>
     <p:sldId id="257" r:id="rId3"/>
@@ -19,6 +16,8 @@
     <p:sldId id="264" r:id="rId10"/>
     <p:sldId id="265" r:id="rId11"/>
     <p:sldId id="266" r:id="rId12"/>
+    <p:sldId id="267" r:id="rId13"/>
+    <p:sldId id="268" r:id="rId14"/>
   </p:sldIdLst>
   <p:sldSz cx="9144000" cy="5143500" type="screen16x9"/>
   <p:notesSz cx="6858000" cy="9144000"/>
@@ -134,437 +133,6 @@
     </p:ext>
   </p:extLst>
 </p:presentation>
-</file>
-
-<file path=ppt/notesMasters/notesMaster1.xml><?xml version="1.0" encoding="utf-8"?>
-<p:notesMaster xmlns:a="http://schemas.openxmlformats.org/drawingml/2006/main" xmlns:r="http://schemas.openxmlformats.org/officeDocument/2006/relationships" xmlns:p="http://schemas.openxmlformats.org/presentationml/2006/main">
-  <p:cSld>
-    <p:bg>
-      <p:bgRef idx="1001">
-        <a:schemeClr val="bg1"/>
-      </p:bgRef>
-    </p:bg>
-    <p:spTree>
-      <p:nvGrpSpPr>
-        <p:cNvPr id="1" name=""/>
-        <p:cNvGrpSpPr/>
-        <p:nvPr/>
-      </p:nvGrpSpPr>
-      <p:grpSpPr>
-        <a:xfrm>
-          <a:off x="0" y="0"/>
-          <a:ext cx="0" cy="0"/>
-          <a:chOff x="0" y="0"/>
-          <a:chExt cx="0" cy="0"/>
-        </a:xfrm>
-      </p:grpSpPr>
-      <p:sp>
-        <p:nvSpPr>
-          <p:cNvPr id="2" name="Header Placeholder 1"/>
-          <p:cNvSpPr>
-            <a:spLocks noGrp="1"/>
-          </p:cNvSpPr>
-          <p:nvPr>
-            <p:ph type="hdr" sz="quarter"/>
-          </p:nvPr>
-        </p:nvSpPr>
-        <p:spPr>
-          <a:xfrm>
-            <a:off x="0" y="0"/>
-            <a:ext cx="2971800" cy="458788"/>
-          </a:xfrm>
-          <a:prstGeom prst="rect">
-            <a:avLst/>
-          </a:prstGeom>
-        </p:spPr>
-        <p:txBody>
-          <a:bodyPr vert="horz" lIns="91440" tIns="45720" rIns="91440" bIns="45720" rtlCol="0"/>
-          <a:lstStyle>
-            <a:lvl1pPr algn="l">
-              <a:defRPr sz="1200"/>
-            </a:lvl1pPr>
-          </a:lstStyle>
-          <a:p>
-            <a:endParaRPr lang="en-US"/>
-          </a:p>
-        </p:txBody>
-      </p:sp>
-      <p:sp>
-        <p:nvSpPr>
-          <p:cNvPr id="3" name="Date Placeholder 2"/>
-          <p:cNvSpPr>
-            <a:spLocks noGrp="1"/>
-          </p:cNvSpPr>
-          <p:nvPr>
-            <p:ph type="dt" idx="1"/>
-          </p:nvPr>
-        </p:nvSpPr>
-        <p:spPr>
-          <a:xfrm>
-            <a:off x="3884613" y="0"/>
-            <a:ext cx="2971800" cy="458788"/>
-          </a:xfrm>
-          <a:prstGeom prst="rect">
-            <a:avLst/>
-          </a:prstGeom>
-        </p:spPr>
-        <p:txBody>
-          <a:bodyPr vert="horz" lIns="91440" tIns="45720" rIns="91440" bIns="45720" rtlCol="0"/>
-          <a:lstStyle>
-            <a:lvl1pPr algn="r">
-              <a:defRPr sz="1200"/>
-            </a:lvl1pPr>
-          </a:lstStyle>
-          <a:p>
-            <a:fld id="{0F9C1CCF-B725-44A7-AA57-5E433BD85C9F}" type="datetimeFigureOut">
-              <a:rPr lang="en-US" smtClean="0"/>
-              <a:t>1/2/22</a:t>
-            </a:fld>
-            <a:endParaRPr lang="en-US"/>
-          </a:p>
-        </p:txBody>
-      </p:sp>
-      <p:sp>
-        <p:nvSpPr>
-          <p:cNvPr id="4" name="Slide Image Placeholder 3"/>
-          <p:cNvSpPr>
-            <a:spLocks noGrp="1" noRot="1" noChangeAspect="1"/>
-          </p:cNvSpPr>
-          <p:nvPr>
-            <p:ph type="sldImg" idx="2"/>
-          </p:nvPr>
-        </p:nvSpPr>
-        <p:spPr>
-          <a:xfrm>
-            <a:off x="685800" y="1143000"/>
-            <a:ext cx="5486400" cy="3086100"/>
-          </a:xfrm>
-          <a:prstGeom prst="rect">
-            <a:avLst/>
-          </a:prstGeom>
-          <a:noFill/>
-          <a:ln w="12700">
-            <a:solidFill>
-              <a:prstClr val="black"/>
-            </a:solidFill>
-          </a:ln>
-        </p:spPr>
-        <p:txBody>
-          <a:bodyPr vert="horz" lIns="91440" tIns="45720" rIns="91440" bIns="45720" rtlCol="0" anchor="ctr"/>
-          <a:lstStyle/>
-          <a:p>
-            <a:endParaRPr lang="en-US"/>
-          </a:p>
-        </p:txBody>
-      </p:sp>
-      <p:sp>
-        <p:nvSpPr>
-          <p:cNvPr id="5" name="Notes Placeholder 4"/>
-          <p:cNvSpPr>
-            <a:spLocks noGrp="1"/>
-          </p:cNvSpPr>
-          <p:nvPr>
-            <p:ph type="body" sz="quarter" idx="3"/>
-          </p:nvPr>
-        </p:nvSpPr>
-        <p:spPr>
-          <a:xfrm>
-            <a:off x="685800" y="4400550"/>
-            <a:ext cx="5486400" cy="3600450"/>
-          </a:xfrm>
-          <a:prstGeom prst="rect">
-            <a:avLst/>
-          </a:prstGeom>
-        </p:spPr>
-        <p:txBody>
-          <a:bodyPr vert="horz" lIns="91440" tIns="45720" rIns="91440" bIns="45720" rtlCol="0"/>
-          <a:lstStyle/>
-          <a:p>
-            <a:pPr lvl="0"/>
-            <a:r>
-              <a:rPr lang="en-US"/>
-              <a:t>Click to edit Master text styles</a:t>
-            </a:r>
-          </a:p>
-          <a:p>
-            <a:pPr lvl="1"/>
-            <a:r>
-              <a:rPr lang="en-US"/>
-              <a:t>Second level</a:t>
-            </a:r>
-          </a:p>
-          <a:p>
-            <a:pPr lvl="2"/>
-            <a:r>
-              <a:rPr lang="en-US"/>
-              <a:t>Third level</a:t>
-            </a:r>
-          </a:p>
-          <a:p>
-            <a:pPr lvl="3"/>
-            <a:r>
-              <a:rPr lang="en-US"/>
-              <a:t>Fourth level</a:t>
-            </a:r>
-          </a:p>
-          <a:p>
-            <a:pPr lvl="4"/>
-            <a:r>
-              <a:rPr lang="en-US"/>
-              <a:t>Fifth level</a:t>
-            </a:r>
-          </a:p>
-        </p:txBody>
-      </p:sp>
-      <p:sp>
-        <p:nvSpPr>
-          <p:cNvPr id="6" name="Footer Placeholder 5"/>
-          <p:cNvSpPr>
-            <a:spLocks noGrp="1"/>
-          </p:cNvSpPr>
-          <p:nvPr>
-            <p:ph type="ftr" sz="quarter" idx="4"/>
-          </p:nvPr>
-        </p:nvSpPr>
-        <p:spPr>
-          <a:xfrm>
-            <a:off x="0" y="8685213"/>
-            <a:ext cx="2971800" cy="458787"/>
-          </a:xfrm>
-          <a:prstGeom prst="rect">
-            <a:avLst/>
-          </a:prstGeom>
-        </p:spPr>
-        <p:txBody>
-          <a:bodyPr vert="horz" lIns="91440" tIns="45720" rIns="91440" bIns="45720" rtlCol="0" anchor="b"/>
-          <a:lstStyle>
-            <a:lvl1pPr algn="l">
-              <a:defRPr sz="1200"/>
-            </a:lvl1pPr>
-          </a:lstStyle>
-          <a:p>
-            <a:endParaRPr lang="en-US"/>
-          </a:p>
-        </p:txBody>
-      </p:sp>
-      <p:sp>
-        <p:nvSpPr>
-          <p:cNvPr id="7" name="Slide Number Placeholder 6"/>
-          <p:cNvSpPr>
-            <a:spLocks noGrp="1"/>
-          </p:cNvSpPr>
-          <p:nvPr>
-            <p:ph type="sldNum" sz="quarter" idx="5"/>
-          </p:nvPr>
-        </p:nvSpPr>
-        <p:spPr>
-          <a:xfrm>
-            <a:off x="3884613" y="8685213"/>
-            <a:ext cx="2971800" cy="458787"/>
-          </a:xfrm>
-          <a:prstGeom prst="rect">
-            <a:avLst/>
-          </a:prstGeom>
-        </p:spPr>
-        <p:txBody>
-          <a:bodyPr vert="horz" lIns="91440" tIns="45720" rIns="91440" bIns="45720" rtlCol="0" anchor="b"/>
-          <a:lstStyle>
-            <a:lvl1pPr algn="r">
-              <a:defRPr sz="1200"/>
-            </a:lvl1pPr>
-          </a:lstStyle>
-          <a:p>
-            <a:fld id="{18BDFEC3-8487-43E8-A154-7C12CBC1FFF2}" type="slidenum">
-              <a:rPr lang="en-US" smtClean="0"/>
-              <a:t>‹#›</a:t>
-            </a:fld>
-            <a:endParaRPr lang="en-US"/>
-          </a:p>
-        </p:txBody>
-      </p:sp>
-    </p:spTree>
-    <p:extLst>
-      <p:ext uri="{BB962C8B-B14F-4D97-AF65-F5344CB8AC3E}">
-        <p14:creationId xmlns:p14="http://schemas.microsoft.com/office/powerpoint/2010/main" val="3782709779"/>
-      </p:ext>
-    </p:extLst>
-  </p:cSld>
-  <p:clrMap bg1="lt1" tx1="dk1" bg2="lt2" tx2="dk2" accent1="accent1" accent2="accent2" accent3="accent3" accent4="accent4" accent5="accent5" accent6="accent6" hlink="hlink" folHlink="folHlink"/>
-  <p:notesStyle>
-    <a:lvl1pPr marL="0" algn="l" defTabSz="914400" rtl="0" eaLnBrk="1" latinLnBrk="0" hangingPunct="1">
-      <a:defRPr sz="1200" kern="1200">
-        <a:solidFill>
-          <a:schemeClr val="tx1"/>
-        </a:solidFill>
-        <a:latin typeface="+mn-lt"/>
-        <a:ea typeface="+mn-ea"/>
-        <a:cs typeface="+mn-cs"/>
-      </a:defRPr>
-    </a:lvl1pPr>
-    <a:lvl2pPr marL="457200" algn="l" defTabSz="914400" rtl="0" eaLnBrk="1" latinLnBrk="0" hangingPunct="1">
-      <a:defRPr sz="1200" kern="1200">
-        <a:solidFill>
-          <a:schemeClr val="tx1"/>
-        </a:solidFill>
-        <a:latin typeface="+mn-lt"/>
-        <a:ea typeface="+mn-ea"/>
-        <a:cs typeface="+mn-cs"/>
-      </a:defRPr>
-    </a:lvl2pPr>
-    <a:lvl3pPr marL="914400" algn="l" defTabSz="914400" rtl="0" eaLnBrk="1" latinLnBrk="0" hangingPunct="1">
-      <a:defRPr sz="1200" kern="1200">
-        <a:solidFill>
-          <a:schemeClr val="tx1"/>
-        </a:solidFill>
-        <a:latin typeface="+mn-lt"/>
-        <a:ea typeface="+mn-ea"/>
-        <a:cs typeface="+mn-cs"/>
-      </a:defRPr>
-    </a:lvl3pPr>
-    <a:lvl4pPr marL="1371600" algn="l" defTabSz="914400" rtl="0" eaLnBrk="1" latinLnBrk="0" hangingPunct="1">
-      <a:defRPr sz="1200" kern="1200">
-        <a:solidFill>
-          <a:schemeClr val="tx1"/>
-        </a:solidFill>
-        <a:latin typeface="+mn-lt"/>
-        <a:ea typeface="+mn-ea"/>
-        <a:cs typeface="+mn-cs"/>
-      </a:defRPr>
-    </a:lvl4pPr>
-    <a:lvl5pPr marL="1828800" algn="l" defTabSz="914400" rtl="0" eaLnBrk="1" latinLnBrk="0" hangingPunct="1">
-      <a:defRPr sz="1200" kern="1200">
-        <a:solidFill>
-          <a:schemeClr val="tx1"/>
-        </a:solidFill>
-        <a:latin typeface="+mn-lt"/>
-        <a:ea typeface="+mn-ea"/>
-        <a:cs typeface="+mn-cs"/>
-      </a:defRPr>
-    </a:lvl5pPr>
-    <a:lvl6pPr marL="2286000" algn="l" defTabSz="914400" rtl="0" eaLnBrk="1" latinLnBrk="0" hangingPunct="1">
-      <a:defRPr sz="1200" kern="1200">
-        <a:solidFill>
-          <a:schemeClr val="tx1"/>
-        </a:solidFill>
-        <a:latin typeface="+mn-lt"/>
-        <a:ea typeface="+mn-ea"/>
-        <a:cs typeface="+mn-cs"/>
-      </a:defRPr>
-    </a:lvl6pPr>
-    <a:lvl7pPr marL="2743200" algn="l" defTabSz="914400" rtl="0" eaLnBrk="1" latinLnBrk="0" hangingPunct="1">
-      <a:defRPr sz="1200" kern="1200">
-        <a:solidFill>
-          <a:schemeClr val="tx1"/>
-        </a:solidFill>
-        <a:latin typeface="+mn-lt"/>
-        <a:ea typeface="+mn-ea"/>
-        <a:cs typeface="+mn-cs"/>
-      </a:defRPr>
-    </a:lvl7pPr>
-    <a:lvl8pPr marL="3200400" algn="l" defTabSz="914400" rtl="0" eaLnBrk="1" latinLnBrk="0" hangingPunct="1">
-      <a:defRPr sz="1200" kern="1200">
-        <a:solidFill>
-          <a:schemeClr val="tx1"/>
-        </a:solidFill>
-        <a:latin typeface="+mn-lt"/>
-        <a:ea typeface="+mn-ea"/>
-        <a:cs typeface="+mn-cs"/>
-      </a:defRPr>
-    </a:lvl8pPr>
-    <a:lvl9pPr marL="3657600" algn="l" defTabSz="914400" rtl="0" eaLnBrk="1" latinLnBrk="0" hangingPunct="1">
-      <a:defRPr sz="1200" kern="1200">
-        <a:solidFill>
-          <a:schemeClr val="tx1"/>
-        </a:solidFill>
-        <a:latin typeface="+mn-lt"/>
-        <a:ea typeface="+mn-ea"/>
-        <a:cs typeface="+mn-cs"/>
-      </a:defRPr>
-    </a:lvl9pPr>
-  </p:notesStyle>
-</p:notesMaster>
-</file>
-
-<file path=ppt/notesSlides/notesSlide1.xml><?xml version="1.0" encoding="utf-8"?>
-<p:notes xmlns:a="http://schemas.openxmlformats.org/drawingml/2006/main" xmlns:r="http://schemas.openxmlformats.org/officeDocument/2006/relationships" xmlns:p="http://schemas.openxmlformats.org/presentationml/2006/main">
-  <p:cSld>
-    <p:spTree>
-      <p:nvGrpSpPr>
-        <p:cNvPr id="1" name=""/>
-        <p:cNvGrpSpPr/>
-        <p:nvPr/>
-      </p:nvGrpSpPr>
-      <p:grpSpPr>
-        <a:xfrm>
-          <a:off x="0" y="0"/>
-          <a:ext cx="0" cy="0"/>
-          <a:chOff x="0" y="0"/>
-          <a:chExt cx="0" cy="0"/>
-        </a:xfrm>
-      </p:grpSpPr>
-      <p:sp>
-        <p:nvSpPr>
-          <p:cNvPr id="2" name="Slide Image Placeholder 1"/>
-          <p:cNvSpPr>
-            <a:spLocks noGrp="1" noRot="1" noChangeAspect="1"/>
-          </p:cNvSpPr>
-          <p:nvPr>
-            <p:ph type="sldImg"/>
-          </p:nvPr>
-        </p:nvSpPr>
-        <p:spPr/>
-      </p:sp>
-      <p:sp>
-        <p:nvSpPr>
-          <p:cNvPr id="3" name="Notes Placeholder 2"/>
-          <p:cNvSpPr>
-            <a:spLocks noGrp="1"/>
-          </p:cNvSpPr>
-          <p:nvPr>
-            <p:ph type="body" idx="1"/>
-          </p:nvPr>
-        </p:nvSpPr>
-        <p:spPr/>
-        <p:txBody>
-          <a:bodyPr/>
-          <a:lstStyle/>
-          <a:p>
-            <a:pPr lvl="0" indent="0" marL="0">
-              <a:buNone/>
-            </a:pPr>
-            <a:r>
-              <a:rPr/>
-              <a:t>Сказать спокойно: это не наказание и не торг. Это проверка самостоятельности.</a:t>
-            </a:r>
-          </a:p>
-        </p:txBody>
-      </p:sp>
-      <p:sp>
-        <p:nvSpPr>
-          <p:cNvPr id="4" name="Slide Number Placeholder 3"/>
-          <p:cNvSpPr>
-            <a:spLocks noGrp="1"/>
-          </p:cNvSpPr>
-          <p:nvPr>
-            <p:ph type="sldNum" sz="quarter" idx="10"/>
-          </p:nvPr>
-        </p:nvSpPr>
-        <p:spPr/>
-        <p:txBody>
-          <a:bodyPr/>
-          <a:lstStyle/>
-          <a:p>
-            <a:fld id="{18BDFEC3-8487-43E8-A154-7C12CBC1FFF2}" type="slidenum">
-              <a:rPr lang="en-US"/>
-              <a:t>2</a:t>
-            </a:fld>
-            <a:endParaRPr lang="en-US"/>
-          </a:p>
-        </p:txBody>
-      </p:sp>
-    </p:spTree>
-  </p:cSld>
-</p:notes>
 </file>
 
 <file path=ppt/slideLayouts/slideLayout1.xml><?xml version="1.0" encoding="utf-8"?>
@@ -3587,15 +3155,11 @@
             <a:pPr lvl="0" indent="0" marL="0">
               <a:buNone/>
             </a:pPr>
-            <a:r>
-              <a:rPr/>
-              <a:t>Дорожная карта тендерного направления</a:t>
-            </a:r>
             <a:br/>
             <a:br/>
             <a:r>
               <a:rPr/>
-              <a:t>ред. 2</a:t>
+              <a:t>Дорожная карта тендерного направления</a:t>
             </a:r>
           </a:p>
         </p:txBody>
@@ -3620,7 +3184,7 @@
             </a:pPr>
             <a:r>
               <a:rPr/>
-              <a:t>26.05.2026</a:t>
+              <a:t>ред. 3 · 26.05.2026</a:t>
             </a:r>
           </a:p>
         </p:txBody>
@@ -3667,7 +3231,7 @@
             </a:pPr>
             <a:r>
               <a:rPr/>
-              <a:t>Плавающая встреча</a:t>
+              <a:t>Что Антон не делает</a:t>
             </a:r>
           </a:p>
         </p:txBody>
@@ -3687,47 +3251,38 @@
           <a:bodyPr/>
           <a:lstStyle/>
           <a:p>
-            <a:pPr lvl="0" indent="0" marL="0">
-              <a:buNone/>
-            </a:pPr>
-            <a:r>
-              <a:rPr/>
-              <a:t>Один слот в течение недели.</a:t>
-            </a:r>
-          </a:p>
-          <a:p>
-            <a:pPr lvl="0"/>
-            <a:r>
-              <a:rPr/>
-              <a:t>0–10: отчёт по 6 критериям.</a:t>
-            </a:r>
-          </a:p>
-          <a:p>
-            <a:pPr lvl="0"/>
-            <a:r>
-              <a:rPr/>
-              <a:t>10–25: вопросы собственника.</a:t>
-            </a:r>
-          </a:p>
-          <a:p>
-            <a:pPr lvl="0"/>
-            <a:r>
-              <a:rPr/>
-              <a:t>25–40: дебиторка, маржа, риски.</a:t>
-            </a:r>
-          </a:p>
-          <a:p>
-            <a:pPr lvl="0"/>
-            <a:r>
-              <a:rPr/>
-              <a:t>40–55: блокеры и приоритеты.</a:t>
-            </a:r>
-          </a:p>
-          <a:p>
-            <a:pPr lvl="0"/>
-            <a:r>
-              <a:rPr/>
-              <a:t>55–60: фиксация решений.</a:t>
+            <a:pPr lvl="0"/>
+            <a:r>
+              <a:rPr/>
+              <a:t>Не занимается наймом.</a:t>
+            </a:r>
+          </a:p>
+          <a:p>
+            <a:pPr lvl="0"/>
+            <a:r>
+              <a:rPr/>
+              <a:t>Не готовит отчётность.</a:t>
+            </a:r>
+          </a:p>
+          <a:p>
+            <a:pPr lvl="0"/>
+            <a:r>
+              <a:rPr/>
+              <a:t>Не собирает цифры за Данила.</a:t>
+            </a:r>
+          </a:p>
+          <a:p>
+            <a:pPr lvl="0"/>
+            <a:r>
+              <a:rPr/>
+              <a:t>Не решает обычные тендерные вопросы между встречами.</a:t>
+            </a:r>
+          </a:p>
+          <a:p>
+            <a:pPr lvl="0"/>
+            <a:r>
+              <a:rPr/>
+              <a:t>Не пишет заявки, письма и документы за Данила.</a:t>
             </a:r>
           </a:p>
         </p:txBody>
@@ -3774,6 +3329,206 @@
             </a:pPr>
             <a:r>
               <a:rPr/>
+              <a:t>Формат отчётности</a:t>
+            </a:r>
+          </a:p>
+        </p:txBody>
+      </p:sp>
+      <p:sp>
+        <p:nvSpPr>
+          <p:cNvPr id="3" name="Content Placeholder 2"/>
+          <p:cNvSpPr>
+            <a:spLocks noGrp="1"/>
+          </p:cNvSpPr>
+          <p:nvPr>
+            <p:ph idx="1"/>
+          </p:nvPr>
+        </p:nvSpPr>
+        <p:spPr/>
+        <p:txBody>
+          <a:bodyPr/>
+          <a:lstStyle/>
+          <a:p>
+            <a:pPr lvl="0" indent="0" marL="0">
+              <a:buNone/>
+            </a:pPr>
+            <a:r>
+              <a:rPr/>
+              <a:t>Один реестр + короткий недельный отчёт.</a:t>
+            </a:r>
+          </a:p>
+          <a:p>
+            <a:pPr lvl="0"/>
+            <a:r>
+              <a:rPr/>
+              <a:t>Реестр: номер, площадка, заказчик, сумма, стадия, срок, следующий шаг, маржа, дебиторка, риск, блокер.</a:t>
+            </a:r>
+          </a:p>
+          <a:p>
+            <a:pPr lvl="0"/>
+            <a:r>
+              <a:rPr/>
+              <a:t>Отчёт: оплачено, ожидается к оплате, дебиторка 30/60/90, чистая прибыль, топ-5 рисков, 3 результата, 3 приоритета.</a:t>
+            </a:r>
+          </a:p>
+          <a:p>
+            <a:pPr lvl="0"/>
+            <a:r>
+              <a:rPr/>
+              <a:t>Вопрос к Антону: факт, риск, деньги, срок, 2–3 варианта, рекомендация Данила.</a:t>
+            </a:r>
+          </a:p>
+        </p:txBody>
+      </p:sp>
+    </p:spTree>
+  </p:cSld>
+</p:sld>
+</file>
+
+<file path=ppt/slides/slide12.xml><?xml version="1.0" encoding="utf-8"?>
+<p:sld xmlns:a="http://schemas.openxmlformats.org/drawingml/2006/main" xmlns:r="http://schemas.openxmlformats.org/officeDocument/2006/relationships" xmlns:p="http://schemas.openxmlformats.org/presentationml/2006/main">
+  <p:cSld>
+    <p:spTree>
+      <p:nvGrpSpPr>
+        <p:cNvPr id="1" name=""/>
+        <p:cNvGrpSpPr/>
+        <p:nvPr/>
+      </p:nvGrpSpPr>
+      <p:grpSpPr>
+        <a:xfrm>
+          <a:off x="0" y="0"/>
+          <a:ext cx="0" cy="0"/>
+          <a:chOff x="0" y="0"/>
+          <a:chExt cx="0" cy="0"/>
+        </a:xfrm>
+      </p:grpSpPr>
+      <p:sp>
+        <p:nvSpPr>
+          <p:cNvPr id="2" name="Title 1"/>
+          <p:cNvSpPr>
+            <a:spLocks noGrp="1"/>
+          </p:cNvSpPr>
+          <p:nvPr>
+            <p:ph type="title"/>
+          </p:nvPr>
+        </p:nvSpPr>
+        <p:spPr/>
+        <p:txBody>
+          <a:bodyPr/>
+          <a:lstStyle/>
+          <a:p>
+            <a:pPr lvl="0" indent="0" marL="0">
+              <a:buNone/>
+            </a:pPr>
+            <a:r>
+              <a:rPr/>
+              <a:t>Плавающая встреча</a:t>
+            </a:r>
+          </a:p>
+        </p:txBody>
+      </p:sp>
+      <p:sp>
+        <p:nvSpPr>
+          <p:cNvPr id="3" name="Content Placeholder 2"/>
+          <p:cNvSpPr>
+            <a:spLocks noGrp="1"/>
+          </p:cNvSpPr>
+          <p:nvPr>
+            <p:ph idx="1"/>
+          </p:nvPr>
+        </p:nvSpPr>
+        <p:spPr/>
+        <p:txBody>
+          <a:bodyPr/>
+          <a:lstStyle/>
+          <a:p>
+            <a:pPr lvl="0" indent="0" marL="0">
+              <a:buNone/>
+            </a:pPr>
+            <a:r>
+              <a:rPr/>
+              <a:t>Один слот 45–60 минут в течение недели.</a:t>
+            </a:r>
+          </a:p>
+          <a:p>
+            <a:pPr lvl="0"/>
+            <a:r>
+              <a:rPr/>
+              <a:t>0–10: отчёт по 6 критериям.</a:t>
+            </a:r>
+          </a:p>
+          <a:p>
+            <a:pPr lvl="0"/>
+            <a:r>
+              <a:rPr/>
+              <a:t>10–25: вопросы собственника.</a:t>
+            </a:r>
+          </a:p>
+          <a:p>
+            <a:pPr lvl="0"/>
+            <a:r>
+              <a:rPr/>
+              <a:t>25–40: дебиторка, маржа, риски.</a:t>
+            </a:r>
+          </a:p>
+          <a:p>
+            <a:pPr lvl="0"/>
+            <a:r>
+              <a:rPr/>
+              <a:t>40–55: блокеры и приоритеты.</a:t>
+            </a:r>
+          </a:p>
+          <a:p>
+            <a:pPr lvl="0"/>
+            <a:r>
+              <a:rPr/>
+              <a:t>55–60: решения — кто делает, что делает, до какой даты.</a:t>
+            </a:r>
+          </a:p>
+        </p:txBody>
+      </p:sp>
+    </p:spTree>
+  </p:cSld>
+</p:sld>
+</file>
+
+<file path=ppt/slides/slide13.xml><?xml version="1.0" encoding="utf-8"?>
+<p:sld xmlns:a="http://schemas.openxmlformats.org/drawingml/2006/main" xmlns:r="http://schemas.openxmlformats.org/officeDocument/2006/relationships" xmlns:p="http://schemas.openxmlformats.org/presentationml/2006/main">
+  <p:cSld>
+    <p:spTree>
+      <p:nvGrpSpPr>
+        <p:cNvPr id="1" name=""/>
+        <p:cNvGrpSpPr/>
+        <p:nvPr/>
+      </p:nvGrpSpPr>
+      <p:grpSpPr>
+        <a:xfrm>
+          <a:off x="0" y="0"/>
+          <a:ext cx="0" cy="0"/>
+          <a:chOff x="0" y="0"/>
+          <a:chExt cx="0" cy="0"/>
+        </a:xfrm>
+      </p:grpSpPr>
+      <p:sp>
+        <p:nvSpPr>
+          <p:cNvPr id="2" name="Title 1"/>
+          <p:cNvSpPr>
+            <a:spLocks noGrp="1"/>
+          </p:cNvSpPr>
+          <p:nvPr>
+            <p:ph type="title"/>
+          </p:nvPr>
+        </p:nvSpPr>
+        <p:spPr/>
+        <p:txBody>
+          <a:bodyPr/>
+          <a:lstStyle/>
+          <a:p>
+            <a:pPr lvl="0" indent="0" marL="0">
+              <a:buNone/>
+            </a:pPr>
+            <a:r>
+              <a:rPr/>
               <a:t>Стержень разговора</a:t>
             </a:r>
           </a:p>
@@ -3799,7 +3554,7 @@
             </a:pPr>
             <a:r>
               <a:rPr/>
-              <a:t>31% — не компенсация за усталость и не премия за хороший месяц.</a:t>
+              <a:t>31% я подтверждаю как возможный уровень. Но это не премия за усталость. Это доля руководителя самостоятельного направления.</a:t>
             </a:r>
           </a:p>
           <a:p>
@@ -3808,7 +3563,7 @@
             </a:pPr>
             <a:r>
               <a:rPr/>
-              <a:t>Это цена самостоятельного направления, которое показывает цифры и само держит порядок.</a:t>
+              <a:t>Я даю тебе слот и решения собственника. Ты приносишь факты, варианты, рекомендацию, деньги, риски и реестр.</a:t>
             </a:r>
           </a:p>
         </p:txBody>
@@ -3875,21 +3630,24 @@
           <a:bodyPr/>
           <a:lstStyle/>
           <a:p>
-            <a:pPr lvl="0" indent="0" marL="0">
-              <a:buNone/>
-            </a:pPr>
+            <a:pPr lvl="0"/>
             <a:r>
               <a:rPr/>
               <a:t>31% — не премия за хороший месяц.</a:t>
             </a:r>
           </a:p>
           <a:p>
-            <a:pPr lvl="0" indent="0" marL="0">
-              <a:buNone/>
-            </a:pPr>
-            <a:r>
-              <a:rPr/>
-              <a:t>Это новая доля за самостоятельное направление, где порядок видно в цифрах, сроках и решениях.</a:t>
+            <a:pPr lvl="0"/>
+            <a:r>
+              <a:rPr/>
+              <a:t>Это доля руководителя самостоятельного направления.</a:t>
+            </a:r>
+          </a:p>
+          <a:p>
+            <a:pPr lvl="0"/>
+            <a:r>
+              <a:rPr/>
+              <a:t>Самостоятельность видна в цифрах, сроках, деньгах и решениях.</a:t>
             </a:r>
           </a:p>
         </p:txBody>
@@ -3936,7 +3694,7 @@
             </a:pPr>
             <a:r>
               <a:rPr/>
-              <a:t>Что исправили</a:t>
+              <a:t>Что подтвердил совет экспертов</a:t>
             </a:r>
           </a:p>
         </p:txBody>
@@ -3959,28 +3717,28 @@
             <a:pPr lvl="0"/>
             <a:r>
               <a:rPr/>
-              <a:t>Неработающая автоматизация убрана из критериев: пока контур не работает, он не может быть условием.</a:t>
-            </a:r>
-          </a:p>
-          <a:p>
-            <a:pPr lvl="0"/>
-            <a:r>
-              <a:rPr/>
-              <a:t>Фиксированный день убран: встреча плавающая в течение недели.</a:t>
-            </a:r>
-          </a:p>
-          <a:p>
-            <a:pPr lvl="0"/>
-            <a:r>
-              <a:rPr/>
-              <a:t>Найм не на Антоне.</a:t>
-            </a:r>
-          </a:p>
-          <a:p>
-            <a:pPr lvl="0"/>
-            <a:r>
-              <a:rPr/>
-              <a:t>Отчётность не на Антоне: Данил сам приносит цифры и статусы.</a:t>
+              <a:t>План рабочий: 25% база, 31% только за устойчивую автономность.</a:t>
+            </a:r>
+          </a:p>
+          <a:p>
+            <a:pPr lvl="0"/>
+            <a:r>
+              <a:rPr/>
+              <a:t>Отчётность полностью на Даниле.</a:t>
+            </a:r>
+          </a:p>
+          <a:p>
+            <a:pPr lvl="0"/>
+            <a:r>
+              <a:rPr/>
+              <a:t>Антон даёт недельный собственнический слот, но не становится диспетчером.</a:t>
+            </a:r>
+          </a:p>
+          <a:p>
+            <a:pPr lvl="0"/>
+            <a:r>
+              <a:rPr/>
+              <a:t>Доля считается от полученной чистой прибыли, не от оборота и не из дебиторки.</a:t>
             </a:r>
           </a:p>
         </p:txBody>
@@ -4047,30 +3805,31 @@
           <a:bodyPr/>
           <a:lstStyle/>
           <a:p>
-            <a:pPr lvl="0" indent="0" marL="0">
-              <a:buNone/>
-            </a:pPr>
+            <a:pPr lvl="0"/>
             <a:r>
               <a:rPr/>
               <a:t>Все 6 критериев держатся 3 месяца подряд.</a:t>
             </a:r>
           </a:p>
           <a:p>
-            <a:pPr lvl="0" indent="0" marL="0">
-              <a:buNone/>
-            </a:pPr>
-            <a:r>
-              <a:rPr/>
-              <a:t>Один срыв по любому критерию — счётчик начинается заново.</a:t>
-            </a:r>
-          </a:p>
-          <a:p>
-            <a:pPr lvl="0" indent="0" marL="0">
-              <a:buNone/>
-            </a:pPr>
-            <a:r>
-              <a:rPr/>
-              <a:t>Не 5 из 6. Не «почти». Все шесть.</a:t>
+            <a:pPr lvl="0"/>
+            <a:r>
+              <a:rPr/>
+              <a:t>Один контролируемый срыв — счётчик начинается заново.</a:t>
+            </a:r>
+          </a:p>
+          <a:p>
+            <a:pPr lvl="0"/>
+            <a:r>
+              <a:rPr/>
+              <a:t>Сначала 2 недели на сбор реестра и утверждение формата отчёта.</a:t>
+            </a:r>
+          </a:p>
+          <a:p>
+            <a:pPr lvl="0"/>
+            <a:r>
+              <a:rPr/>
+              <a:t>31% применяется на будущий период, не задним числом.</a:t>
             </a:r>
           </a:p>
         </p:txBody>
@@ -4178,7 +3937,7 @@
             </a:pPr>
             <a:r>
               <a:rPr/>
-              <a:t>Недельный отчёт готов до встречи.</a:t>
+              <a:t>Недельный отчёт готов за 12–24 часа до встречи.</a:t>
             </a:r>
           </a:p>
           <a:p>
@@ -4187,7 +3946,7 @@
             </a:pPr>
             <a:r>
               <a:rPr/>
-              <a:t>К Антону — только по списку собственника.</a:t>
+              <a:t>К Антону — только вопросы собственника.</a:t>
             </a:r>
           </a:p>
         </p:txBody>
@@ -4234,7 +3993,7 @@
             </a:pPr>
             <a:r>
               <a:rPr/>
-              <a:t>Список собственника</a:t>
+              <a:t>Что считается срывом</a:t>
             </a:r>
           </a:p>
         </p:txBody>
@@ -4254,54 +4013,45 @@
           <a:bodyPr/>
           <a:lstStyle/>
           <a:p>
-            <a:pPr lvl="0" indent="0" marL="0">
-              <a:buNone/>
-            </a:pPr>
-            <a:r>
-              <a:rPr/>
-              <a:t>К Антону попадают только вопросы:</a:t>
-            </a:r>
-          </a:p>
-          <a:p>
-            <a:pPr lvl="0"/>
-            <a:r>
-              <a:rPr/>
-              <a:t>контракт выше 1 000 000 ₽ или новый крупный заказчик;</a:t>
-            </a:r>
-          </a:p>
-          <a:p>
-            <a:pPr lvl="0"/>
-            <a:r>
-              <a:rPr/>
-              <a:t>постоплата больше 60 дней;</a:t>
-            </a:r>
-          </a:p>
-          <a:p>
-            <a:pPr lvl="0"/>
-            <a:r>
-              <a:rPr/>
-              <a:t>претензия, штраф, расторжение, суд;</a:t>
-            </a:r>
-          </a:p>
-          <a:p>
-            <a:pPr lvl="0"/>
-            <a:r>
-              <a:rPr/>
-              <a:t>закупка или субподряд выше 200 000 ₽;</a:t>
-            </a:r>
-          </a:p>
-          <a:p>
-            <a:pPr lvl="0"/>
-            <a:r>
-              <a:rPr/>
-              <a:t>новое направление или схема работы;</a:t>
-            </a:r>
-          </a:p>
-          <a:p>
-            <a:pPr lvl="0"/>
-            <a:r>
-              <a:rPr/>
-              <a:t>изменение доли, лимитов, правил.</a:t>
+            <a:pPr lvl="0"/>
+            <a:r>
+              <a:rPr/>
+              <a:t>Тендер или контракт не внесён в реестр.</a:t>
+            </a:r>
+          </a:p>
+          <a:p>
+            <a:pPr lvl="0"/>
+            <a:r>
+              <a:rPr/>
+              <a:t>Срок потерян по внутренней причине.</a:t>
+            </a:r>
+          </a:p>
+          <a:p>
+            <a:pPr lvl="0"/>
+            <a:r>
+              <a:rPr/>
+              <a:t>Красный риск не показан заранее.</a:t>
+            </a:r>
+          </a:p>
+          <a:p>
+            <a:pPr lvl="0"/>
+            <a:r>
+              <a:rPr/>
+              <a:t>Нет маржи или прямых расходов по контракту.</a:t>
+            </a:r>
+          </a:p>
+          <a:p>
+            <a:pPr lvl="0"/>
+            <a:r>
+              <a:rPr/>
+              <a:t>Нет плана по дебиторке.</a:t>
+            </a:r>
+          </a:p>
+          <a:p>
+            <a:pPr lvl="0"/>
+            <a:r>
+              <a:rPr/>
+              <a:t>Вопрос принесён без факта, вариантов и рекомендации.</a:t>
             </a:r>
           </a:p>
         </p:txBody>
@@ -4348,7 +4098,7 @@
             </a:pPr>
             <a:r>
               <a:rPr/>
-              <a:t>Что Антон даёт</a:t>
+              <a:t>Что не считается срывом Данила</a:t>
             </a:r>
           </a:p>
         </p:txBody>
@@ -4371,28 +4121,37 @@
             <a:pPr lvl="0"/>
             <a:r>
               <a:rPr/>
-              <a:t>Плавающий слот раз в неделю: 45–60 минут.</a:t>
-            </a:r>
-          </a:p>
-          <a:p>
-            <a:pPr lvl="0"/>
-            <a:r>
-              <a:rPr/>
-              <a:t>Решение по вопросам собственника.</a:t>
-            </a:r>
-          </a:p>
-          <a:p>
-            <a:pPr lvl="0"/>
-            <a:r>
-              <a:rPr/>
-              <a:t>Правила расчёта 31%.</a:t>
-            </a:r>
-          </a:p>
-          <a:p>
-            <a:pPr lvl="0"/>
-            <a:r>
-              <a:rPr/>
-              <a:t>Последнее слово по крупным деньгам, рискам и правилам.</a:t>
+              <a:t>Задержка заказчика.</a:t>
+            </a:r>
+          </a:p>
+          <a:p>
+            <a:pPr lvl="0"/>
+            <a:r>
+              <a:rPr/>
+              <a:t>Сбой площадки.</a:t>
+            </a:r>
+          </a:p>
+          <a:p>
+            <a:pPr lvl="0"/>
+            <a:r>
+              <a:rPr/>
+              <a:t>Перенос поставщика.</a:t>
+            </a:r>
+          </a:p>
+          <a:p>
+            <a:pPr lvl="0"/>
+            <a:r>
+              <a:rPr/>
+              <a:t>Задержка решения Антона.</a:t>
+            </a:r>
+          </a:p>
+          <a:p>
+            <a:pPr lvl="0" indent="0" marL="0">
+              <a:buNone/>
+            </a:pPr>
+            <a:r>
+              <a:rPr/>
+              <a:t>Но только если риск заранее внесён в реестр, подсвечен и по нему есть план.</a:t>
             </a:r>
           </a:p>
         </p:txBody>
@@ -4439,7 +4198,7 @@
             </a:pPr>
             <a:r>
               <a:rPr/>
-              <a:t>Что Антон не делает</a:t>
+              <a:t>Формула денег</a:t>
             </a:r>
           </a:p>
         </p:txBody>
@@ -4462,35 +4221,28 @@
             <a:pPr lvl="0"/>
             <a:r>
               <a:rPr/>
-              <a:t>Не занимается наймом.</a:t>
-            </a:r>
-          </a:p>
-          <a:p>
-            <a:pPr lvl="0"/>
-            <a:r>
-              <a:rPr/>
-              <a:t>Не готовит отчётность.</a:t>
-            </a:r>
-          </a:p>
-          <a:p>
-            <a:pPr lvl="0"/>
-            <a:r>
-              <a:rPr/>
-              <a:t>Не собирает цифры за Данила.</a:t>
-            </a:r>
-          </a:p>
-          <a:p>
-            <a:pPr lvl="0"/>
-            <a:r>
-              <a:rPr/>
-              <a:t>Не решает обычные тендерные вопросы между встречами.</a:t>
-            </a:r>
-          </a:p>
-          <a:p>
-            <a:pPr lvl="0"/>
-            <a:r>
-              <a:rPr/>
-              <a:t>Не пишет заявки, письма и документы за Данила.</a:t>
+              <a:t>31% считается только от фактически полученной чистой прибыли.</a:t>
+            </a:r>
+          </a:p>
+          <a:p>
+            <a:pPr lvl="0"/>
+            <a:r>
+              <a:rPr/>
+              <a:t>Чистая прибыль = поступившие деньги − прямые расходы.</a:t>
+            </a:r>
+          </a:p>
+          <a:p>
+            <a:pPr lvl="0"/>
+            <a:r>
+              <a:rPr/>
+              <a:t>Прямые расходы: закупка, логистика, подрядчики, гарантии, комиссии, выезды, замены, штрафы, пени, удержания.</a:t>
+            </a:r>
+          </a:p>
+          <a:p>
+            <a:pPr lvl="0"/>
+            <a:r>
+              <a:rPr/>
+              <a:t>Если деньги не пришли или прибыль не считается — базы для 31% нет.</a:t>
             </a:r>
           </a:p>
         </p:txBody>
@@ -4537,7 +4289,7 @@
             </a:pPr>
             <a:r>
               <a:rPr/>
-              <a:t>Что Данил приносит</a:t>
+              <a:t>Список собственника</a:t>
             </a:r>
           </a:p>
         </p:txBody>
@@ -4562,56 +4314,49 @@
             </a:pPr>
             <a:r>
               <a:rPr/>
-              <a:t>До встречи:</a:t>
-            </a:r>
-          </a:p>
-          <a:p>
-            <a:pPr lvl="0"/>
-            <a:r>
-              <a:rPr/>
-              <a:t>реестр тендеров и контрактов;</a:t>
-            </a:r>
-          </a:p>
-          <a:p>
-            <a:pPr lvl="0"/>
-            <a:r>
-              <a:rPr/>
-              <a:t>дебиторку и план взыскания;</a:t>
-            </a:r>
-          </a:p>
-          <a:p>
-            <a:pPr lvl="0"/>
-            <a:r>
-              <a:rPr/>
-              <a:t>маржу по контрактам;</a:t>
-            </a:r>
-          </a:p>
-          <a:p>
-            <a:pPr lvl="0"/>
-            <a:r>
-              <a:rPr/>
-              <a:t>блокеры;</a:t>
-            </a:r>
-          </a:p>
-          <a:p>
-            <a:pPr lvl="0"/>
-            <a:r>
-              <a:rPr/>
-              <a:t>3 результата прошлой недели;</a:t>
-            </a:r>
-          </a:p>
-          <a:p>
-            <a:pPr lvl="0"/>
-            <a:r>
-              <a:rPr/>
-              <a:t>3 приоритета следующей недели;</a:t>
-            </a:r>
-          </a:p>
-          <a:p>
-            <a:pPr lvl="0"/>
-            <a:r>
-              <a:rPr/>
-              <a:t>вопросы к Антону только из списка собственника.</a:t>
+              <a:t>К Антону попадают только:</a:t>
+            </a:r>
+          </a:p>
+          <a:p>
+            <a:pPr lvl="0"/>
+            <a:r>
+              <a:rPr/>
+              <a:t>контракт выше 1 000 000 ₽ или новый крупный заказчик;</a:t>
+            </a:r>
+          </a:p>
+          <a:p>
+            <a:pPr lvl="0"/>
+            <a:r>
+              <a:rPr/>
+              <a:t>постоплата больше 60 дней или риск крупной дебиторки;</a:t>
+            </a:r>
+          </a:p>
+          <a:p>
+            <a:pPr lvl="0"/>
+            <a:r>
+              <a:rPr/>
+              <a:t>претензия, штраф, расторжение, суд;</a:t>
+            </a:r>
+          </a:p>
+          <a:p>
+            <a:pPr lvl="0"/>
+            <a:r>
+              <a:rPr/>
+              <a:t>закупка или субподряд выше 200 000 ₽;</a:t>
+            </a:r>
+          </a:p>
+          <a:p>
+            <a:pPr lvl="0"/>
+            <a:r>
+              <a:rPr/>
+              <a:t>новое направление, площадка или схема;</a:t>
+            </a:r>
+          </a:p>
+          <a:p>
+            <a:pPr lvl="0"/>
+            <a:r>
+              <a:rPr/>
+              <a:t>изменение доли, лимитов и правил.</a:t>
             </a:r>
           </a:p>
         </p:txBody>

</xml_diff>